<commit_message>
Fix double-unescaping in tester XML entity decoding
decodeXml replaced &amp; first, so a literal &amp;lt; in slide XML decoded
to &lt; and then to a real < — CodeQL js/double-escaping (high). Decode
&amp; last instead, and cover the case in the e2e fixture: a run holding
an escaped literal must survive the decode -> translate -> re-encode
round trip byte-for-byte.

Co-Authored-By: Claude Fable 5 <noreply@anthropic.com>
Claude-Session: https://claude.ai/code/session_016z7YRmkeAyY77gjhHAGhU9
</commit_message>
<xml_diff>
--- a/test/fixtures/sample.pptx
+++ b/test/fixtures/sample.pptx
@@ -28,6 +28,12 @@
               <a:t>Contact: sales@example.com</a:t>
             </a:r>
           </a:p>
+          <a:p>
+            <a:r>
+              <a:rPr lang="en-US"/>
+              <a:t>Escaped literal: &amp;lt;tag&amp;gt;</a:t>
+            </a:r>
+          </a:p>
         </p:txBody>
       </p:sp>
     </p:spTree>

</xml_diff>